<commit_message>
Small modifications to slides
</commit_message>
<xml_diff>
--- a/slide_decks/Clustering-demo1.pptx
+++ b/slide_decks/Clustering-demo1.pptx
@@ -149,6 +149,9 @@
     <p:ext uri="{EFAFB233-063F-42B5-8137-9DF3F51BA10A}">
       <p15:sldGuideLst xmlns:p15="http://schemas.microsoft.com/office/powerpoint/2012/main"/>
     </p:ext>
+    <p:ext uri="{2D200454-40CA-4A62-9FC3-DE9A4176ACB9}">
+      <p15:notesGuideLst xmlns:p15="http://schemas.microsoft.com/office/powerpoint/2012/main"/>
+    </p:ext>
   </p:extLst>
 </p:presentation>
 </file>
@@ -247,7 +250,7 @@
           <a:p>
             <a:fld id="{80D5DBC8-1DC3-1648-A64E-0BC218623802}" type="datetimeFigureOut">
               <a:rPr lang="en-US" smtClean="0"/>
-              <a:t>10/28/25</a:t>
+              <a:t>10/31/25</a:t>
             </a:fld>
             <a:endParaRPr lang="en-US"/>
           </a:p>
@@ -424,7 +427,7 @@
           <a:p>
             <a:fld id="{E9721789-7C0D-184A-B027-0FCD7B64D4EB}" type="datetimeFigureOut">
               <a:rPr lang="en-US" smtClean="0"/>
-              <a:t>10/28/25</a:t>
+              <a:t>10/31/25</a:t>
             </a:fld>
             <a:endParaRPr lang="en-US"/>
           </a:p>
@@ -859,15 +862,42 @@
               <a:rPr lang="en-CA" b="1" dirty="0"/>
               <a:t>Ok, so let’s begin.</a:t>
             </a:r>
+          </a:p>
+          <a:p>
+            <a:pPr marL="0" marR="0" lvl="0" indent="0" algn="l" defTabSz="914400" rtl="0" eaLnBrk="1" fontAlgn="auto" latinLnBrk="0" hangingPunct="1">
+              <a:lnSpc>
+                <a:spcPct val="100000"/>
+              </a:lnSpc>
+              <a:spcBef>
+                <a:spcPts val="0"/>
+              </a:spcBef>
+              <a:spcAft>
+                <a:spcPts val="0"/>
+              </a:spcAft>
+              <a:buClrTx/>
+              <a:buSzTx/>
+              <a:buFontTx/>
+              <a:buNone/>
+              <a:tabLst/>
+              <a:defRPr/>
+            </a:pPr>
+            <a:r>
+              <a:rPr lang="en-CA" dirty="0"/>
+              <a:t>This lesson would fit within </a:t>
+            </a:r>
+            <a:r>
+              <a:rPr lang="en-CA" b="1" dirty="0"/>
+              <a:t>INF2190: Introduction to Data Analytics</a:t>
+            </a:r>
+            <a:r>
+              <a:rPr lang="en-CA" dirty="0"/>
+              <a:t>, taught after students have learned about data pre-processing and methods like classification.</a:t>
+            </a:r>
+          </a:p>
+          <a:p>
             <a:br>
               <a:rPr lang="en-CA" dirty="0"/>
             </a:br>
-            <a:r>
-              <a:rPr lang="en-CA" dirty="0"/>
-              <a:t>In this first demonstration, we’ll explore how we can group similar observations when we don’t yet know the ‘right’ answer — also known as clustering.</a:t>
-            </a:r>
-          </a:p>
-          <a:p>
             <a:endParaRPr lang="en-CA" dirty="0"/>
           </a:p>
           <a:p>
@@ -1198,7 +1228,7 @@
             </a:r>
             <a:r>
               <a:rPr lang="en-CA" sz="4000" dirty="0"/>
-              <a:t>— how close each penguin is to its group’s average. The smaller the inertia, the better the clustering.</a:t>
+              <a:t>— how close each data point is to its group’s average. The smaller the inertia, the better the clustering.</a:t>
             </a:r>
           </a:p>
         </p:txBody>
@@ -1303,19 +1333,6 @@
             </a:r>
           </a:p>
           <a:p>
-            <a:pPr rtl="0">
-              <a:spcBef>
-                <a:spcPts val="1500"/>
-              </a:spcBef>
-              <a:spcAft>
-                <a:spcPts val="1500"/>
-              </a:spcAft>
-            </a:pPr>
-            <a:endParaRPr lang="en-CA" b="0" dirty="0">
-              <a:effectLst/>
-            </a:endParaRPr>
-          </a:p>
-          <a:p>
             <a:pPr rtl="0" fontAlgn="base">
               <a:spcBef>
                 <a:spcPts val="1500"/>
@@ -1326,6 +1343,35 @@
               <a:buFont typeface="+mj-lt"/>
               <a:buAutoNum type="arabicPeriod"/>
             </a:pPr>
+            <a:endParaRPr lang="en-CA" sz="1200" b="0" i="0" u="none" strike="noStrike" dirty="0">
+              <a:solidFill>
+                <a:schemeClr val="tx1"/>
+              </a:solidFill>
+              <a:effectLst/>
+              <a:latin typeface="+mn-lt"/>
+            </a:endParaRPr>
+          </a:p>
+          <a:p>
+            <a:pPr rtl="0" fontAlgn="base">
+              <a:spcBef>
+                <a:spcPts val="1500"/>
+              </a:spcBef>
+              <a:spcAft>
+                <a:spcPts val="1500"/>
+              </a:spcAft>
+              <a:buFont typeface="+mj-lt"/>
+              <a:buAutoNum type="arabicPeriod"/>
+            </a:pPr>
+            <a:r>
+              <a:rPr lang="en-CA" sz="1200" b="0" i="0" u="none" strike="noStrike" dirty="0">
+                <a:solidFill>
+                  <a:schemeClr val="tx1"/>
+                </a:solidFill>
+                <a:effectLst/>
+                <a:latin typeface="+mn-lt"/>
+              </a:rPr>
+              <a:t>In this example, there are 4 observations A to D that all belong to a cluster and </a:t>
+            </a:r>
             <a:r>
               <a:rPr lang="en-CA" sz="1800" b="0" i="0" u="none" strike="noStrike" dirty="0">
                 <a:solidFill>
@@ -1334,7 +1380,7 @@
                 <a:effectLst/>
                 <a:latin typeface="Arial" panose="020B0604020202020204" pitchFamily="34" charset="0"/>
               </a:rPr>
-              <a:t>Each data point in the cluster has two or more features (e.g., x variable and y variable). </a:t>
+              <a:t>each observation has two or more features (e.g., x variable and y variable). </a:t>
             </a:r>
           </a:p>
           <a:p>
@@ -1659,7 +1705,7 @@
                 <a:effectLst/>
                 <a:latin typeface="Arial" panose="020B0604020202020204" pitchFamily="34" charset="0"/>
               </a:rPr>
-              <a:t>If a penguin's flipper and bill lengths are very close to the centroid, the line will be short. This means that the penguin is similar to the "average" penguin in the cluster.</a:t>
+              <a:t>If a penguin's flipper and bill lengths are very close to the centroid, the line will be short, like observation C. This means that the penguin is similar to the "average" penguin in the cluster.</a:t>
             </a:r>
           </a:p>
           <a:p>
@@ -1681,7 +1727,7 @@
                 <a:effectLst/>
                 <a:latin typeface="Arial" panose="020B0604020202020204" pitchFamily="34" charset="0"/>
               </a:rPr>
-              <a:t>If the penguin is far from the centroid, the line will be long, indicating that this penguin is different from the average penguin in the cluster.</a:t>
+              <a:t>If the penguin is far from the centroid, the line will be long, like observation D indicating that this penguin is different from the average penguin in the cluster.</a:t>
             </a:r>
           </a:p>
           <a:p>
@@ -1929,7 +1975,27 @@
                 <a:effectLst/>
                 <a:latin typeface="Arial" panose="020B0604020202020204" pitchFamily="34" charset="0"/>
               </a:rPr>
-              <a:t>To get the total Within-Cluster Sum of Squared Distances , you simply sum the values across all clusters. </a:t>
+              <a:t>To get the total Within-Cluster Sum of Squared Distances , you simply sum the within cluster sum of squared </a:t>
+            </a:r>
+            <a:r>
+              <a:rPr lang="en-CA" sz="1800" b="0" i="0" u="none" strike="noStrike" dirty="0" err="1">
+                <a:solidFill>
+                  <a:srgbClr val="000000"/>
+                </a:solidFill>
+                <a:effectLst/>
+                <a:latin typeface="Arial" panose="020B0604020202020204" pitchFamily="34" charset="0"/>
+              </a:rPr>
+              <a:t>distacne</a:t>
+            </a:r>
+            <a:r>
+              <a:rPr lang="en-CA" sz="1800" b="0" i="0" u="none" strike="noStrike" dirty="0">
+                <a:solidFill>
+                  <a:srgbClr val="000000"/>
+                </a:solidFill>
+                <a:effectLst/>
+                <a:latin typeface="Arial" panose="020B0604020202020204" pitchFamily="34" charset="0"/>
+              </a:rPr>
+              <a:t> values across all clusters. </a:t>
             </a:r>
           </a:p>
           <a:p>
@@ -1962,7 +2028,7 @@
                 <a:effectLst/>
                 <a:latin typeface="Arial" panose="020B0604020202020204" pitchFamily="34" charset="0"/>
               </a:rPr>
-              <a:t>The goal is to minimize this total Within-Cluster Sum of Squared Distances to ensure that the data points are as close as possible to their respective centroids.</a:t>
+              <a:t>The goal is to minimize this total value to ensure that the data points are as close as possible to their respective centroids.</a:t>
             </a:r>
             <a:endParaRPr lang="en-CA" b="0" dirty="0">
               <a:effectLst/>
@@ -2153,7 +2219,7 @@
                 <a:effectLst/>
                 <a:latin typeface="Arial" panose="020B0604020202020204" pitchFamily="34" charset="0"/>
               </a:rPr>
-              <a:t>. This is a key decision because </a:t>
+              <a:t>. so K = 3 This is a key decision because </a:t>
             </a:r>
             <a:r>
               <a:rPr lang="en-CA" sz="1800" b="1" i="0" u="none" strike="noStrike" dirty="0">
@@ -2841,7 +2907,7 @@
                 <a:effectLst/>
                 <a:latin typeface="Arial" panose="020B0604020202020204" pitchFamily="34" charset="0"/>
               </a:rPr>
-              <a:t>—are repeated over and over, each time adjusting the clusters slightly until the assignments stabilize. This means the data points no longer change clusters, and the centroids stop moving.</a:t>
+              <a:t>—are repeated over and over until the labels no longer change, and the centroids stop moving.</a:t>
             </a:r>
           </a:p>
           <a:p>
@@ -3187,7 +3253,7 @@
             </a:pPr>
             <a:r>
               <a:rPr lang="en-CA" dirty="0"/>
-              <a:t>It's worth noting that sometimes K-means starts off with bad guesses.</a:t>
+              <a:t>It's worth noting that sometimes K-means starts off with bad random guesses.</a:t>
             </a:r>
           </a:p>
           <a:p>
@@ -3212,7 +3278,7 @@
                 <a:effectLst/>
                 <a:latin typeface="Arial" panose="020B0604020202020204" pitchFamily="34" charset="0"/>
               </a:rPr>
-              <a:t>This typically happens due to poor initializations. Remember that K-means begins by randomly assigning data points to a cluster, which generates our initial cluster centers. If these centers are poorly placed, the algorithm may converge to a less-than-ideal solution that doesn't reflect the best possible clustering.</a:t>
+              <a:t>This typically happens due to poor initializations. Remember that K-means begins by randomly assigning data points to a cluster, which generates our initial cluster centers. If these centers are poorly placed, the algorithm may converge to a suboptimal or  less-than-ideal solution that doesn't reflect the best possible clustering.</a:t>
             </a:r>
             <a:endParaRPr lang="en-CA" b="0" dirty="0">
               <a:effectLst/>
@@ -3669,7 +3735,7 @@
                 <a:effectLst/>
                 <a:latin typeface="Arial" panose="020B0604020202020204" pitchFamily="34" charset="0"/>
               </a:rPr>
-              <a:t>The goal is to find a value of K that balances these issues: too small and we lose meaningful groupings, too large and we overcomplicate the structure.</a:t>
+              <a:t>The goal is to find a value of K that balances these issues: too small and we lose meaningful groupings, too large and we overcomplicate the structure of our data.</a:t>
             </a:r>
             <a:endParaRPr lang="en-CA" b="0" dirty="0">
               <a:effectLst/>
@@ -4537,7 +4603,7 @@
             </a:r>
             <a:r>
               <a:rPr lang="en-CA" sz="9600" dirty="0"/>
-              <a:t> to handle and explore our data — think of it as a faster, more flexible version of Excel.</a:t>
+              <a:t> as we are going to import it as PD to handle and explore our data — think of it as a faster, more flexible version of Excel.</a:t>
             </a:r>
           </a:p>
           <a:p>
@@ -4554,7 +4620,7 @@
             </a:r>
             <a:r>
               <a:rPr lang="en-CA" sz="9600" dirty="0"/>
-              <a:t> for creating visualizations, like the elbow curve we’ll use to find the best number of clusters.</a:t>
+              <a:t> which we are importing as PLT, which will allow us to creating visualizations, like scatter plots of our cluster groupings and the elbow curve we’ll use to find the best number of clusters.</a:t>
             </a:r>
           </a:p>
           <a:p>
@@ -4648,7 +4714,7 @@
             </a:br>
             <a:r>
               <a:rPr lang="en-CA" sz="9600" dirty="0"/>
-              <a:t>This keeps our results in a </a:t>
+              <a:t>What this is doing is asking scikit learn to to keep our results in a </a:t>
             </a:r>
             <a:r>
               <a:rPr lang="en-CA" sz="9600" dirty="0" err="1"/>
@@ -4656,7 +4722,7 @@
             </a:r>
             <a:r>
               <a:rPr lang="en-CA" sz="9600" dirty="0"/>
-              <a:t> format, which makes it easier to inspect, index, or add new columns later on.</a:t>
+              <a:t> format, which makes it easier to inspect, index, or add new columns to our data later on.</a:t>
             </a:r>
             <a:endParaRPr lang="en-CA" sz="7200" dirty="0"/>
           </a:p>
@@ -4869,6 +4935,12 @@
           <a:p>
             <a:endParaRPr lang="en-CA" sz="5400" dirty="0"/>
           </a:p>
+          <a:p>
+            <a:r>
+              <a:rPr lang="en-CA" sz="5400" dirty="0"/>
+              <a:t>So just quickly looking at our data, we can see flipper length is on a much larger scale than bill length.</a:t>
+            </a:r>
+          </a:p>
         </p:txBody>
       </p:sp>
       <p:sp>
@@ -5037,31 +5109,30 @@
           <a:p>
             <a:r>
               <a:rPr lang="en-CA" dirty="0"/>
-              <a:t>Before we start clustering, we need to make sure all our variables are on the same scale.</a:t>
-            </a:r>
-          </a:p>
-          <a:p>
+              <a:t>And we talked about how K-means measures </a:t>
+            </a:r>
+            <a:r>
+              <a:rPr lang="en-CA" b="1" dirty="0"/>
+              <a:t>distance</a:t>
+            </a:r>
+            <a:r>
+              <a:rPr lang="en-CA" dirty="0"/>
+              <a:t> between points.</a:t>
+            </a:r>
             <a:br>
               <a:rPr lang="en-CA" dirty="0"/>
             </a:br>
             <a:r>
               <a:rPr lang="en-CA" dirty="0"/>
-              <a:t>Remember — K-means measures </a:t>
-            </a:r>
-            <a:r>
-              <a:rPr lang="en-CA" b="1" dirty="0"/>
-              <a:t>distance</a:t>
+              <a:t>So if one variable, like flipper length, has much larger numeric values than another, such as bill length, it will dominate the distance calculation even if that variable </a:t>
+            </a:r>
+            <a:r>
+              <a:rPr lang="en-CA" dirty="0" err="1"/>
+              <a:t>isnt</a:t>
             </a:r>
             <a:r>
               <a:rPr lang="en-CA" dirty="0"/>
-              <a:t> between points.</a:t>
-            </a:r>
-            <a:br>
-              <a:rPr lang="en-CA" dirty="0"/>
-            </a:br>
-            <a:r>
-              <a:rPr lang="en-CA" dirty="0"/>
-              <a:t>If one variable, like flipper length, has much larger numeric values than another, such as bill length, it will dominate the distance calculation.</a:t>
+              <a:t> necessarily more meaningful to the grouping of the penguins.</a:t>
             </a:r>
           </a:p>
           <a:p>
@@ -5141,13 +5212,38 @@
           <a:p>
             <a:r>
               <a:rPr lang="en-CA" dirty="0"/>
+              <a:t>To avoid overriding our original data, we're going to save this transformation as a new </a:t>
+            </a:r>
+            <a:r>
+              <a:rPr lang="en-CA" dirty="0" err="1"/>
+              <a:t>dataframe</a:t>
+            </a:r>
+            <a:r>
+              <a:rPr lang="en-CA" dirty="0"/>
+              <a:t> called </a:t>
+            </a:r>
+            <a:r>
+              <a:rPr lang="en-CA" dirty="0" err="1"/>
+              <a:t>penguins_scaled</a:t>
+            </a:r>
+            <a:r>
+              <a:rPr lang="en-CA" dirty="0"/>
+              <a:t>.</a:t>
+            </a:r>
+          </a:p>
+          <a:p>
+            <a:endParaRPr lang="en-CA" dirty="0"/>
+          </a:p>
+          <a:p>
+            <a:r>
+              <a:rPr lang="en-CA" dirty="0"/>
               <a:t>Now,</a:t>
             </a:r>
           </a:p>
           <a:p>
             <a:r>
               <a:rPr lang="en-CA" dirty="0"/>
-              <a:t>We check the first few rows of the processed data, we see that our variables are on similar scales.</a:t>
+              <a:t>We check the first few rows of the processed data, we see that our variables are on similar scales which is exactly what we want!</a:t>
             </a:r>
           </a:p>
           <a:p>
@@ -5312,7 +5408,7 @@
           <a:p>
             <a:r>
               <a:rPr lang="en-CA" sz="9600" dirty="0"/>
-              <a:t>We’ll start by setting up our model using the </a:t>
+              <a:t>We’ll start by initializing our model using the </a:t>
             </a:r>
             <a:r>
               <a:rPr lang="en-CA" sz="9600" dirty="0" err="1"/>
@@ -5376,7 +5472,15 @@
             </a:r>
             <a:r>
               <a:rPr lang="en-CA" sz="9600" dirty="0"/>
-              <a:t> — that means K-means will try ten different random starting points and keep the best result — the one with the smallest total within-cluster sum of squared distance. 10 is the default value for this argument</a:t>
+              <a:t> — that means K-means will try ten different random </a:t>
+            </a:r>
+            <a:r>
+              <a:rPr lang="en-CA" sz="9600" dirty="0" err="1"/>
+              <a:t>initalizations</a:t>
+            </a:r>
+            <a:r>
+              <a:rPr lang="en-CA" sz="9600" dirty="0"/>
+              <a:t> and keep the best result — the one with the lowest total within-cluster sum of squared distance. 10 is the default value for this argument</a:t>
             </a:r>
           </a:p>
           <a:p>
@@ -5396,7 +5500,7 @@
             </a:br>
             <a:r>
               <a:rPr lang="en-CA" sz="9600" dirty="0"/>
-              <a:t>This is where K-means does all the heavy lifting in the </a:t>
+              <a:t>This is where K-means does all the heavy lifting that we talked about in the </a:t>
             </a:r>
             <a:r>
               <a:rPr lang="en-CA" sz="9600" dirty="0" err="1"/>
@@ -5404,7 +5508,7 @@
             </a:r>
             <a:r>
               <a:rPr lang="en-CA" sz="9600" dirty="0"/>
-              <a:t>— it goes through that two-step process we talked about: assigning points to clusters, updating the cluster centers, and repeating those steps until everything stabilizes.</a:t>
+              <a:t>— it goes through that iterative two-step process of center update and label update, and repeating those steps until no further improvements to the clustering could be made.</a:t>
             </a:r>
           </a:p>
           <a:p>
@@ -5428,7 +5532,7 @@
             </a:r>
             <a:r>
               <a:rPr lang="en-CA" sz="9600" dirty="0"/>
-              <a:t>, which tells us which cluster each data point belongs to.</a:t>
+              <a:t>, which tells us which cluster each data point ended up belonging to.</a:t>
             </a:r>
           </a:p>
           <a:p>
@@ -5450,7 +5554,7 @@
             </a:r>
             <a:r>
               <a:rPr lang="en-CA" sz="9600" dirty="0"/>
-              <a:t> — showing which group each penguin falls into.</a:t>
+              <a:t>.</a:t>
             </a:r>
           </a:p>
         </p:txBody>
@@ -5632,7 +5736,7 @@
             </a:br>
             <a:r>
               <a:rPr lang="en-CA" sz="9600" dirty="0"/>
-              <a:t>On the x-axis, we’ve got </a:t>
+              <a:t>On the x-axis, we're indexing </a:t>
             </a:r>
             <a:r>
               <a:rPr lang="en-CA" sz="9600" b="1" dirty="0"/>
@@ -5640,7 +5744,7 @@
             </a:r>
             <a:r>
               <a:rPr lang="en-CA" sz="9600" dirty="0"/>
-              <a:t>, and on the y-axis, </a:t>
+              <a:t>, and on the y-axis we're indexing, </a:t>
             </a:r>
             <a:r>
               <a:rPr lang="en-CA" sz="9600" b="1" dirty="0"/>
@@ -5682,7 +5786,7 @@
             </a:r>
             <a:r>
               <a:rPr lang="en-CA" sz="9600" dirty="0"/>
-              <a:t> to the new column we added earlier, called </a:t>
+              <a:t> to the new column we created earlier, called </a:t>
             </a:r>
             <a:r>
               <a:rPr lang="en-CA" sz="9600" i="1" dirty="0"/>
@@ -5717,6 +5821,83 @@
             <a:r>
               <a:rPr lang="en-CA" sz="9600" dirty="0"/>
               <a:t>That tells matplotlib to color each point based on its cluster label — so penguins that fall into the same group appear in the same color.</a:t>
+            </a:r>
+          </a:p>
+          <a:p>
+            <a:pPr marL="0" marR="0" lvl="0" indent="0" algn="l" defTabSz="914400" rtl="0" eaLnBrk="1" fontAlgn="auto" latinLnBrk="0" hangingPunct="1">
+              <a:lnSpc>
+                <a:spcPct val="100000"/>
+              </a:lnSpc>
+              <a:spcBef>
+                <a:spcPts val="0"/>
+              </a:spcBef>
+              <a:spcAft>
+                <a:spcPts val="0"/>
+              </a:spcAft>
+              <a:buClrTx/>
+              <a:buSzTx/>
+              <a:buFontTx/>
+              <a:buNone/>
+              <a:tabLst/>
+              <a:defRPr/>
+            </a:pPr>
+            <a:endParaRPr lang="en-CA" sz="9600" dirty="0"/>
+          </a:p>
+          <a:p>
+            <a:pPr marL="0" marR="0" lvl="0" indent="0" algn="l" defTabSz="914400" rtl="0" eaLnBrk="1" fontAlgn="auto" latinLnBrk="0" hangingPunct="1">
+              <a:lnSpc>
+                <a:spcPct val="100000"/>
+              </a:lnSpc>
+              <a:spcBef>
+                <a:spcPts val="0"/>
+              </a:spcBef>
+              <a:spcAft>
+                <a:spcPts val="0"/>
+              </a:spcAft>
+              <a:buClrTx/>
+              <a:buSzTx/>
+              <a:buFontTx/>
+              <a:buNone/>
+              <a:tabLst/>
+              <a:defRPr/>
+            </a:pPr>
+            <a:r>
+              <a:rPr lang="en-CA" sz="9600" dirty="0"/>
+              <a:t>We see that clusters are fairly well separated, which suggests that </a:t>
+            </a:r>
+            <a:r>
+              <a:rPr lang="en-CA" sz="9600" b="1" dirty="0"/>
+              <a:t>K = 3</a:t>
+            </a:r>
+            <a:r>
+              <a:rPr lang="en-CA" sz="9600" dirty="0"/>
+              <a:t> was a good choice and that flipper length and bill length do a nice job distinguishing between penguin subtypes.</a:t>
+            </a:r>
+          </a:p>
+          <a:p>
+            <a:pPr marL="0" marR="0" lvl="0" indent="0" algn="l" defTabSz="914400" rtl="0" eaLnBrk="1" fontAlgn="auto" latinLnBrk="0" hangingPunct="1">
+              <a:lnSpc>
+                <a:spcPct val="100000"/>
+              </a:lnSpc>
+              <a:spcBef>
+                <a:spcPts val="0"/>
+              </a:spcBef>
+              <a:spcAft>
+                <a:spcPts val="0"/>
+              </a:spcAft>
+              <a:buClrTx/>
+              <a:buSzTx/>
+              <a:buFontTx/>
+              <a:buNone/>
+              <a:tabLst/>
+              <a:defRPr/>
+            </a:pPr>
+            <a:br>
+              <a:rPr lang="en-CA" sz="9600" dirty="0"/>
+            </a:br>
+            <a:r>
+              <a:rPr lang="en-CA" sz="9600" dirty="0"/>
+              <a:t>There’s still a bit of overlap at the boundaries — that’s expected in real data, since biological traits often vary along a continuum and rarely ever form perfectly distinct groups.</a:t>
             </a:r>
           </a:p>
         </p:txBody>
@@ -5884,7 +6065,7 @@
             </a:r>
             <a:r>
               <a:rPr lang="en-CA" sz="5400" dirty="0"/>
-              <a:t>, which if you recall, measures how close each point is to its cluster center — in other words, how tight the clusters are.</a:t>
+              <a:t>, also known as total within cluster sum of squared distances, which if you recall, measures how close each point is to its cluster center — in other words, how tight the clusters are.</a:t>
             </a:r>
           </a:p>
           <a:p>
@@ -5898,34 +6079,69 @@
           </a:p>
           <a:p>
             <a:r>
+              <a:rPr lang="en-CA" sz="7200" dirty="0"/>
+              <a:t>But the big question is — </a:t>
+            </a:r>
+            <a:r>
+              <a:rPr lang="en-CA" sz="7200" b="1" dirty="0"/>
+              <a:t>how do we know if this is a </a:t>
+            </a:r>
+            <a:r>
+              <a:rPr lang="en-CA" sz="7200" b="1" i="1" dirty="0"/>
+              <a:t>good</a:t>
+            </a:r>
+            <a:r>
+              <a:rPr lang="en-CA" sz="7200" b="1" dirty="0"/>
+              <a:t> inertia value?</a:t>
+            </a:r>
+          </a:p>
+          <a:p>
+            <a:br>
+              <a:rPr lang="en-CA" sz="7200" dirty="0"/>
+            </a:br>
+            <a:r>
+              <a:rPr lang="en-CA" sz="7200" dirty="0"/>
+              <a:t>On its own, inertia doesn’t tell us much, because it naturally gets smaller as we increase the number of clusters.</a:t>
+            </a:r>
+          </a:p>
+          <a:p>
+            <a:endParaRPr lang="en-CA" sz="7200" dirty="0"/>
+          </a:p>
+          <a:p>
+            <a:r>
+              <a:rPr lang="en-CA" sz="7200" dirty="0"/>
+              <a:t>So, instead, we can compare it across different values of </a:t>
+            </a:r>
+            <a:r>
+              <a:rPr lang="en-CA" sz="7200" i="1" dirty="0"/>
+              <a:t>K</a:t>
+            </a:r>
+            <a:r>
+              <a:rPr lang="en-CA" sz="7200" dirty="0"/>
+              <a:t>.</a:t>
+            </a:r>
+            <a:br>
+              <a:rPr lang="en-CA" sz="7200" dirty="0"/>
+            </a:br>
+            <a:r>
+              <a:rPr lang="en-CA" sz="7200" dirty="0"/>
+              <a:t>Let’s run K-means several times </a:t>
+            </a:r>
+            <a:r>
               <a:rPr lang="en-CA" sz="5400" dirty="0"/>
-              <a:t>But the big question is — </a:t>
+              <a:t>with different numbers of clusters, or K, and compare their inertia values to find the optimal number.</a:t>
+            </a:r>
+          </a:p>
+          <a:p>
+            <a:r>
+              <a:rPr lang="en-CA" sz="5400" dirty="0"/>
+              <a:t>We can accomplish this using a simple </a:t>
             </a:r>
             <a:r>
               <a:rPr lang="en-CA" sz="5400" b="1" dirty="0"/>
-              <a:t>how do we know if three clusters is the right number?</a:t>
-            </a:r>
-            <a:br>
-              <a:rPr lang="en-CA" sz="5400" dirty="0"/>
-            </a:br>
-            <a:r>
-              <a:rPr lang="en-CA" sz="5400" dirty="0"/>
-              <a:t>To figure that out, we can run K-means several times with different numbers of clusters and compare their inertia values.</a:t>
-            </a:r>
-          </a:p>
-          <a:p>
-            <a:r>
-              <a:rPr lang="en-CA" sz="5400" dirty="0"/>
-              <a:t>Let’s do that now using a simple </a:t>
-            </a:r>
-            <a:r>
-              <a:rPr lang="en-CA" sz="5400" b="1" dirty="0"/>
-              <a:t>for loop</a:t>
-            </a:r>
-            <a:r>
-              <a:rPr lang="en-CA" sz="5400" dirty="0"/>
-              <a:t>.</a:t>
-            </a:r>
+              <a:t>for loop!</a:t>
+            </a:r>
+            <a:endParaRPr lang="en-CA" sz="5400" dirty="0"/>
           </a:p>
           <a:p>
             <a:br>
@@ -6029,11 +6245,11 @@
             </a:r>
             <a:r>
               <a:rPr lang="en-CA" b="1" dirty="0"/>
-              <a:t>within-cluster sum of squared distances</a:t>
+              <a:t>within-cluster sum of squared distance values </a:t>
             </a:r>
             <a:r>
               <a:rPr lang="en-CA" dirty="0"/>
-              <a:t> for each number of clusters we test.</a:t>
+              <a:t>for each number of k that we are testing.</a:t>
             </a:r>
           </a:p>
           <a:p>
@@ -6101,7 +6317,7 @@
           <a:p>
             <a:r>
               <a:rPr lang="en-CA" dirty="0"/>
-              <a:t>By the end, our list contains </a:t>
+              <a:t>By the end of our loop, our list contains </a:t>
             </a:r>
             <a:r>
               <a:rPr lang="en-CA" b="1" dirty="0"/>
@@ -6109,7 +6325,7 @@
             </a:r>
             <a:r>
               <a:rPr lang="en-CA" dirty="0"/>
-              <a:t>, one for each possible number of clusters.</a:t>
+              <a:t>, one for each possible number of clusters or k.</a:t>
             </a:r>
           </a:p>
           <a:p>
@@ -6248,7 +6464,15 @@
             </a:pPr>
             <a:r>
               <a:rPr lang="en-CA" sz="1800" dirty="0"/>
-              <a:t>Once we’ve done that, we plot </a:t>
+              <a:t>Once we’ve done that, we can use </a:t>
+            </a:r>
+            <a:r>
+              <a:rPr lang="en-CA" sz="1800" dirty="0" err="1"/>
+              <a:t>matplot</a:t>
+            </a:r>
+            <a:r>
+              <a:rPr lang="en-CA" sz="1800" dirty="0"/>
+              <a:t> lib to create a line plot with </a:t>
             </a:r>
             <a:r>
               <a:rPr lang="en-CA" sz="1800" i="1" dirty="0"/>
@@ -6273,7 +6497,7 @@
           <a:p>
             <a:r>
               <a:rPr lang="en-CA" sz="1800" dirty="0"/>
-              <a:t>At first, as we increase K, the inertia drops sharply — because adding more clusters naturally makes the groups tighter.</a:t>
+              <a:t>At first, as we increase K, the total WSSD drops sharply — because adding more clusters naturally makes the groups tighter.</a:t>
             </a:r>
             <a:br>
               <a:rPr lang="en-CA" sz="1800" dirty="0"/>
@@ -6466,7 +6690,7 @@
           <a:p>
             <a:r>
               <a:rPr lang="en-CA" dirty="0"/>
-              <a:t>Let’s end off by quickly reviewing a </a:t>
+              <a:t>Let’s quickly reviewing a </a:t>
             </a:r>
             <a:r>
               <a:rPr lang="en-CA" b="1" dirty="0"/>
@@ -6572,7 +6796,7 @@
             </a:r>
             <a:r>
               <a:rPr lang="en-CA" dirty="0"/>
-              <a:t> the points are within each cluster — the lower the total within cluster sum of squared distances, the better the clustering fit.</a:t>
+              <a:t> the points are within each cluster — the lower the value, the better the clustering fit.</a:t>
             </a:r>
           </a:p>
           <a:p>
@@ -6873,8 +7097,33 @@
           <a:lstStyle/>
           <a:p>
             <a:r>
-              <a:rPr lang="en-US" dirty="0"/>
-              <a:t>Thank you so much, I’d be happy to take any questions!</a:t>
+              <a:rPr lang="en-CA" dirty="0"/>
+              <a:t>To end off, I always emphasize data transparency and reproducibility in my teaching.</a:t>
+            </a:r>
+            <a:br>
+              <a:rPr lang="en-CA" dirty="0"/>
+            </a:br>
+            <a:r>
+              <a:rPr lang="en-CA" dirty="0"/>
+              <a:t>All of the materials for this demo — including the slides, code, and dataset — are publicly available on my GitHub repository.</a:t>
+            </a:r>
+          </a:p>
+          <a:p>
+            <a:br>
+              <a:rPr lang="en-CA" dirty="0"/>
+            </a:br>
+            <a:r>
+              <a:rPr lang="en-CA" dirty="0"/>
+              <a:t>You can scan the QR code on the slide if you’d like to explore them later.</a:t>
+            </a:r>
+          </a:p>
+          <a:p>
+            <a:endParaRPr lang="en-CA" dirty="0"/>
+          </a:p>
+          <a:p>
+            <a:r>
+              <a:rPr lang="en-CA" dirty="0"/>
+              <a:t>Thank you so much for your time — I’d be happy to take any questions!</a:t>
             </a:r>
           </a:p>
         </p:txBody>
@@ -9625,7 +9874,7 @@
             </a:br>
             <a:r>
               <a:rPr lang="en-CA" sz="2800" dirty="0"/>
-              <a:t>If one variable has a much larger range than another — say, income in thousands of dollars versus age in years — that variable can end up dominating the clustering process, even if it’s not more meaningful.</a:t>
+              <a:t>If one variable has a much larger range than another — say, income in thousands of dollars versus age in years — that variable can end up dominating the clustering process, even if it’s not more meaningful to the grouping.</a:t>
             </a:r>
           </a:p>
           <a:p>
@@ -9815,13 +10064,6 @@
             <a:br>
               <a:rPr lang="en-CA" sz="4000" dirty="0"/>
             </a:br>
-            <a:r>
-              <a:rPr lang="en-CA" sz="4000" dirty="0"/>
-              <a:t>If you’d like to explore the data further on your own, there’s a QR code provided that links directly to the full dataset!</a:t>
-            </a:r>
-            <a:endParaRPr lang="en-CA" sz="2800" dirty="0"/>
-          </a:p>
-          <a:p>
             <a:endParaRPr lang="en-CA" sz="2800" dirty="0"/>
           </a:p>
           <a:p>
@@ -10350,7 +10592,7 @@
           <a:p>
             <a:fld id="{C9C1E032-8598-D245-A611-EA3486D38588}" type="datetimeFigureOut">
               <a:rPr lang="en-US" smtClean="0"/>
-              <a:t>10/28/25</a:t>
+              <a:t>10/31/25</a:t>
             </a:fld>
             <a:endParaRPr lang="en-US"/>
           </a:p>
@@ -10520,7 +10762,7 @@
           <a:p>
             <a:fld id="{C9C1E032-8598-D245-A611-EA3486D38588}" type="datetimeFigureOut">
               <a:rPr lang="en-US" smtClean="0"/>
-              <a:t>10/28/25</a:t>
+              <a:t>10/31/25</a:t>
             </a:fld>
             <a:endParaRPr lang="en-US"/>
           </a:p>
@@ -10700,7 +10942,7 @@
           <a:p>
             <a:fld id="{C9C1E032-8598-D245-A611-EA3486D38588}" type="datetimeFigureOut">
               <a:rPr lang="en-US" smtClean="0"/>
-              <a:t>10/28/25</a:t>
+              <a:t>10/31/25</a:t>
             </a:fld>
             <a:endParaRPr lang="en-US"/>
           </a:p>
@@ -10870,7 +11112,7 @@
           <a:p>
             <a:fld id="{C9C1E032-8598-D245-A611-EA3486D38588}" type="datetimeFigureOut">
               <a:rPr lang="en-US" smtClean="0"/>
-              <a:t>10/28/25</a:t>
+              <a:t>10/31/25</a:t>
             </a:fld>
             <a:endParaRPr lang="en-US"/>
           </a:p>
@@ -11116,7 +11358,7 @@
           <a:p>
             <a:fld id="{C9C1E032-8598-D245-A611-EA3486D38588}" type="datetimeFigureOut">
               <a:rPr lang="en-US" smtClean="0"/>
-              <a:t>10/28/25</a:t>
+              <a:t>10/31/25</a:t>
             </a:fld>
             <a:endParaRPr lang="en-US"/>
           </a:p>
@@ -11348,7 +11590,7 @@
           <a:p>
             <a:fld id="{C9C1E032-8598-D245-A611-EA3486D38588}" type="datetimeFigureOut">
               <a:rPr lang="en-US" smtClean="0"/>
-              <a:t>10/28/25</a:t>
+              <a:t>10/31/25</a:t>
             </a:fld>
             <a:endParaRPr lang="en-US"/>
           </a:p>
@@ -11715,7 +11957,7 @@
           <a:p>
             <a:fld id="{C9C1E032-8598-D245-A611-EA3486D38588}" type="datetimeFigureOut">
               <a:rPr lang="en-US" smtClean="0"/>
-              <a:t>10/28/25</a:t>
+              <a:t>10/31/25</a:t>
             </a:fld>
             <a:endParaRPr lang="en-US"/>
           </a:p>
@@ -11833,7 +12075,7 @@
           <a:p>
             <a:fld id="{C9C1E032-8598-D245-A611-EA3486D38588}" type="datetimeFigureOut">
               <a:rPr lang="en-US" smtClean="0"/>
-              <a:t>10/28/25</a:t>
+              <a:t>10/31/25</a:t>
             </a:fld>
             <a:endParaRPr lang="en-US"/>
           </a:p>
@@ -11928,7 +12170,7 @@
           <a:p>
             <a:fld id="{C9C1E032-8598-D245-A611-EA3486D38588}" type="datetimeFigureOut">
               <a:rPr lang="en-US" smtClean="0"/>
-              <a:t>10/28/25</a:t>
+              <a:t>10/31/25</a:t>
             </a:fld>
             <a:endParaRPr lang="en-US"/>
           </a:p>
@@ -12205,7 +12447,7 @@
           <a:p>
             <a:fld id="{C9C1E032-8598-D245-A611-EA3486D38588}" type="datetimeFigureOut">
               <a:rPr lang="en-US" smtClean="0"/>
-              <a:t>10/28/25</a:t>
+              <a:t>10/31/25</a:t>
             </a:fld>
             <a:endParaRPr lang="en-US"/>
           </a:p>
@@ -12462,7 +12704,7 @@
           <a:p>
             <a:fld id="{C9C1E032-8598-D245-A611-EA3486D38588}" type="datetimeFigureOut">
               <a:rPr lang="en-US" smtClean="0"/>
-              <a:t>10/28/25</a:t>
+              <a:t>10/31/25</a:t>
             </a:fld>
             <a:endParaRPr lang="en-US"/>
           </a:p>
@@ -12675,7 +12917,7 @@
           <a:p>
             <a:fld id="{C9C1E032-8598-D245-A611-EA3486D38588}" type="datetimeFigureOut">
               <a:rPr lang="en-US" smtClean="0"/>
-              <a:t>10/28/25</a:t>
+              <a:t>10/31/25</a:t>
             </a:fld>
             <a:endParaRPr lang="en-US"/>
           </a:p>
@@ -14003,8 +14245,8 @@
           </a:p>
         </p:txBody>
       </p:sp>
-      <mc:AlternateContent xmlns:mc="http://schemas.openxmlformats.org/markup-compatibility/2006">
-        <mc:Choice xmlns:a14="http://schemas.microsoft.com/office/drawing/2010/main" Requires="a14">
+      <mc:AlternateContent xmlns:mc="http://schemas.openxmlformats.org/markup-compatibility/2006" xmlns:a14="http://schemas.microsoft.com/office/drawing/2010/main">
+        <mc:Choice Requires="a14">
           <p:sp>
             <p:nvSpPr>
               <p:cNvPr id="3" name="Content Placeholder 2">
@@ -14169,7 +14411,7 @@
             </p:txBody>
           </p:sp>
         </mc:Choice>
-        <mc:Fallback>
+        <mc:Fallback xmlns="">
           <p:sp>
             <p:nvSpPr>
               <p:cNvPr id="3" name="Content Placeholder 2">
@@ -14528,8 +14770,8 @@
           </p:sp>
         </mc:Fallback>
       </mc:AlternateContent>
-      <mc:AlternateContent xmlns:mc="http://schemas.openxmlformats.org/markup-compatibility/2006">
-        <mc:Choice xmlns:a14="http://schemas.microsoft.com/office/drawing/2010/main" Requires="a14">
+      <mc:AlternateContent xmlns:mc="http://schemas.openxmlformats.org/markup-compatibility/2006" xmlns:a14="http://schemas.microsoft.com/office/drawing/2010/main">
+        <mc:Choice Requires="a14">
           <p:graphicFrame>
             <p:nvGraphicFramePr>
               <p:cNvPr id="4" name="Content Placeholder 7">
@@ -14681,6 +14923,7 @@
                         <a:bodyPr/>
                         <a:lstStyle/>
                         <a:p>
+                          <a:pPr/>
                           <a14:m>
                             <m:oMathPara xmlns:m="http://schemas.openxmlformats.org/officeDocument/2006/math">
                               <m:oMathParaPr>
@@ -14810,6 +15053,7 @@
                         <a:bodyPr/>
                         <a:lstStyle/>
                         <a:p>
+                          <a:pPr/>
                           <a14:m>
                             <m:oMathPara xmlns:m="http://schemas.openxmlformats.org/officeDocument/2006/math">
                               <m:oMathParaPr>
@@ -14939,6 +15183,7 @@
                         <a:bodyPr/>
                         <a:lstStyle/>
                         <a:p>
+                          <a:pPr/>
                           <a14:m>
                             <m:oMathPara xmlns:m="http://schemas.openxmlformats.org/officeDocument/2006/math">
                               <m:oMathParaPr>
@@ -15068,6 +15313,7 @@
                         <a:bodyPr/>
                         <a:lstStyle/>
                         <a:p>
+                          <a:pPr/>
                           <a14:m>
                             <m:oMathPara xmlns:m="http://schemas.openxmlformats.org/officeDocument/2006/math">
                               <m:oMathParaPr>
@@ -15196,7 +15442,7 @@
             </a:graphic>
           </p:graphicFrame>
         </mc:Choice>
-        <mc:Fallback>
+        <mc:Fallback xmlns="">
           <p:graphicFrame>
             <p:nvGraphicFramePr>
               <p:cNvPr id="4" name="Content Placeholder 7">
@@ -16273,8 +16519,8 @@
           </a:p>
         </p:txBody>
       </p:sp>
-      <mc:AlternateContent xmlns:mc="http://schemas.openxmlformats.org/markup-compatibility/2006">
-        <mc:Choice xmlns:a14="http://schemas.microsoft.com/office/drawing/2010/main" Requires="a14">
+      <mc:AlternateContent xmlns:mc="http://schemas.openxmlformats.org/markup-compatibility/2006" xmlns:a14="http://schemas.microsoft.com/office/drawing/2010/main">
+        <mc:Choice Requires="a14">
           <p:sp>
             <p:nvSpPr>
               <p:cNvPr id="7" name="Content Placeholder 2">
@@ -17506,7 +17752,7 @@
             </p:txBody>
           </p:sp>
         </mc:Choice>
-        <mc:Fallback>
+        <mc:Fallback xmlns="">
           <p:sp>
             <p:nvSpPr>
               <p:cNvPr id="7" name="Content Placeholder 2">
@@ -17633,8 +17879,8 @@
           </a:p>
         </p:txBody>
       </p:sp>
-      <mc:AlternateContent xmlns:mc="http://schemas.openxmlformats.org/markup-compatibility/2006">
-        <mc:Choice xmlns:a14="http://schemas.microsoft.com/office/drawing/2010/main" Requires="a14">
+      <mc:AlternateContent xmlns:mc="http://schemas.openxmlformats.org/markup-compatibility/2006" xmlns:a14="http://schemas.microsoft.com/office/drawing/2010/main">
+        <mc:Choice Requires="a14">
           <p:sp>
             <p:nvSpPr>
               <p:cNvPr id="10" name="TextBox 9">
@@ -17692,7 +17938,7 @@
             </p:txBody>
           </p:sp>
         </mc:Choice>
-        <mc:Fallback>
+        <mc:Fallback xmlns="">
           <p:sp>
             <p:nvSpPr>
               <p:cNvPr id="10" name="TextBox 9">
@@ -17737,8 +17983,8 @@
           </p:sp>
         </mc:Fallback>
       </mc:AlternateContent>
-      <mc:AlternateContent xmlns:mc="http://schemas.openxmlformats.org/markup-compatibility/2006">
-        <mc:Choice xmlns:a14="http://schemas.microsoft.com/office/drawing/2010/main" Requires="a14">
+      <mc:AlternateContent xmlns:mc="http://schemas.openxmlformats.org/markup-compatibility/2006" xmlns:a14="http://schemas.microsoft.com/office/drawing/2010/main">
+        <mc:Choice Requires="a14">
           <p:sp>
             <p:nvSpPr>
               <p:cNvPr id="11" name="TextBox 10">
@@ -17796,7 +18042,7 @@
             </p:txBody>
           </p:sp>
         </mc:Choice>
-        <mc:Fallback>
+        <mc:Fallback xmlns="">
           <p:sp>
             <p:nvSpPr>
               <p:cNvPr id="11" name="TextBox 10">
@@ -17841,8 +18087,8 @@
           </p:sp>
         </mc:Fallback>
       </mc:AlternateContent>
-      <mc:AlternateContent xmlns:mc="http://schemas.openxmlformats.org/markup-compatibility/2006">
-        <mc:Choice xmlns:a14="http://schemas.microsoft.com/office/drawing/2010/main" Requires="a14">
+      <mc:AlternateContent xmlns:mc="http://schemas.openxmlformats.org/markup-compatibility/2006" xmlns:a14="http://schemas.microsoft.com/office/drawing/2010/main">
+        <mc:Choice Requires="a14">
           <p:sp>
             <p:nvSpPr>
               <p:cNvPr id="12" name="TextBox 11">
@@ -17900,7 +18146,7 @@
             </p:txBody>
           </p:sp>
         </mc:Choice>
-        <mc:Fallback>
+        <mc:Fallback xmlns="">
           <p:sp>
             <p:nvSpPr>
               <p:cNvPr id="12" name="TextBox 11">
@@ -17945,8 +18191,8 @@
           </p:sp>
         </mc:Fallback>
       </mc:AlternateContent>
-      <mc:AlternateContent xmlns:mc="http://schemas.openxmlformats.org/markup-compatibility/2006">
-        <mc:Choice xmlns:a14="http://schemas.microsoft.com/office/drawing/2010/main" Requires="a14">
+      <mc:AlternateContent xmlns:mc="http://schemas.openxmlformats.org/markup-compatibility/2006" xmlns:a14="http://schemas.microsoft.com/office/drawing/2010/main">
+        <mc:Choice Requires="a14">
           <p:sp>
             <p:nvSpPr>
               <p:cNvPr id="13" name="TextBox 12">
@@ -18004,7 +18250,7 @@
             </p:txBody>
           </p:sp>
         </mc:Choice>
-        <mc:Fallback>
+        <mc:Fallback xmlns="">
           <p:sp>
             <p:nvSpPr>
               <p:cNvPr id="13" name="TextBox 12">
@@ -18049,8 +18295,8 @@
           </p:sp>
         </mc:Fallback>
       </mc:AlternateContent>
-      <mc:AlternateContent xmlns:mc="http://schemas.openxmlformats.org/markup-compatibility/2006">
-        <mc:Choice xmlns:a14="http://schemas.microsoft.com/office/drawing/2010/main" Requires="a14">
+      <mc:AlternateContent xmlns:mc="http://schemas.openxmlformats.org/markup-compatibility/2006" xmlns:a14="http://schemas.microsoft.com/office/drawing/2010/main">
+        <mc:Choice Requires="a14">
           <p:sp>
             <p:nvSpPr>
               <p:cNvPr id="14" name="TextBox 13">
@@ -18108,7 +18354,7 @@
             </p:txBody>
           </p:sp>
         </mc:Choice>
-        <mc:Fallback>
+        <mc:Fallback xmlns="">
           <p:sp>
             <p:nvSpPr>
               <p:cNvPr id="14" name="TextBox 13">
@@ -18153,8 +18399,8 @@
           </p:sp>
         </mc:Fallback>
       </mc:AlternateContent>
-      <mc:AlternateContent xmlns:mc="http://schemas.openxmlformats.org/markup-compatibility/2006">
-        <mc:Choice xmlns:a14="http://schemas.microsoft.com/office/drawing/2010/main" Requires="a14">
+      <mc:AlternateContent xmlns:mc="http://schemas.openxmlformats.org/markup-compatibility/2006" xmlns:a14="http://schemas.microsoft.com/office/drawing/2010/main">
+        <mc:Choice Requires="a14">
           <p:sp>
             <p:nvSpPr>
               <p:cNvPr id="15" name="TextBox 14">
@@ -18231,7 +18477,7 @@
             </p:txBody>
           </p:sp>
         </mc:Choice>
-        <mc:Fallback>
+        <mc:Fallback xmlns="">
           <p:sp>
             <p:nvSpPr>
               <p:cNvPr id="15" name="TextBox 14">
@@ -18279,8 +18525,8 @@
           </p:sp>
         </mc:Fallback>
       </mc:AlternateContent>
-      <mc:AlternateContent xmlns:mc="http://schemas.openxmlformats.org/markup-compatibility/2006">
-        <mc:Choice xmlns:a14="http://schemas.microsoft.com/office/drawing/2010/main" Requires="a14">
+      <mc:AlternateContent xmlns:mc="http://schemas.openxmlformats.org/markup-compatibility/2006" xmlns:a14="http://schemas.microsoft.com/office/drawing/2010/main">
+        <mc:Choice Requires="a14">
           <p:sp>
             <p:nvSpPr>
               <p:cNvPr id="16" name="TextBox 15">
@@ -18357,7 +18603,7 @@
             </p:txBody>
           </p:sp>
         </mc:Choice>
-        <mc:Fallback>
+        <mc:Fallback xmlns="">
           <p:sp>
             <p:nvSpPr>
               <p:cNvPr id="16" name="TextBox 15">
@@ -18405,8 +18651,8 @@
           </p:sp>
         </mc:Fallback>
       </mc:AlternateContent>
-      <mc:AlternateContent xmlns:mc="http://schemas.openxmlformats.org/markup-compatibility/2006">
-        <mc:Choice xmlns:a14="http://schemas.microsoft.com/office/drawing/2010/main" Requires="a14">
+      <mc:AlternateContent xmlns:mc="http://schemas.openxmlformats.org/markup-compatibility/2006" xmlns:a14="http://schemas.microsoft.com/office/drawing/2010/main">
+        <mc:Choice Requires="a14">
           <p:sp>
             <p:nvSpPr>
               <p:cNvPr id="17" name="TextBox 16">
@@ -18483,7 +18729,7 @@
             </p:txBody>
           </p:sp>
         </mc:Choice>
-        <mc:Fallback>
+        <mc:Fallback xmlns="">
           <p:sp>
             <p:nvSpPr>
               <p:cNvPr id="17" name="TextBox 16">
@@ -18531,8 +18777,8 @@
           </p:sp>
         </mc:Fallback>
       </mc:AlternateContent>
-      <mc:AlternateContent xmlns:mc="http://schemas.openxmlformats.org/markup-compatibility/2006">
-        <mc:Choice xmlns:a14="http://schemas.microsoft.com/office/drawing/2010/main" Requires="a14">
+      <mc:AlternateContent xmlns:mc="http://schemas.openxmlformats.org/markup-compatibility/2006" xmlns:a14="http://schemas.microsoft.com/office/drawing/2010/main">
+        <mc:Choice Requires="a14">
           <p:sp>
             <p:nvSpPr>
               <p:cNvPr id="18" name="TextBox 17">
@@ -18609,7 +18855,7 @@
             </p:txBody>
           </p:sp>
         </mc:Choice>
-        <mc:Fallback>
+        <mc:Fallback xmlns="">
           <p:sp>
             <p:nvSpPr>
               <p:cNvPr id="18" name="TextBox 17">
@@ -19171,8 +19417,8 @@
           </a:p>
         </p:txBody>
       </p:sp>
-      <mc:AlternateContent xmlns:mc="http://schemas.openxmlformats.org/markup-compatibility/2006">
-        <mc:Choice xmlns:a14="http://schemas.microsoft.com/office/drawing/2010/main" Requires="a14">
+      <mc:AlternateContent xmlns:mc="http://schemas.openxmlformats.org/markup-compatibility/2006" xmlns:a14="http://schemas.microsoft.com/office/drawing/2010/main">
+        <mc:Choice Requires="a14">
           <p:sp>
             <p:nvSpPr>
               <p:cNvPr id="3" name="Content Placeholder 2">
@@ -19453,7 +19699,7 @@
             </p:txBody>
           </p:sp>
         </mc:Choice>
-        <mc:Fallback>
+        <mc:Fallback xmlns="">
           <p:sp>
             <p:nvSpPr>
               <p:cNvPr id="3" name="Content Placeholder 2">
@@ -21249,7 +21495,7 @@
                 </a:solidFill>
                 <a:effectLst/>
               </a:rPr>
-              <a:t>Select the clustering result with the lowest final total WSSD.</a:t>
+              <a:t>Select the clustering result with the lowest total WSSD.</a:t>
             </a:r>
           </a:p>
           <a:p>
@@ -22550,8 +22796,8 @@
           </a:extLst>
         </p:spPr>
       </p:pic>
-      <mc:AlternateContent xmlns:mc="http://schemas.openxmlformats.org/markup-compatibility/2006">
-        <mc:Choice xmlns:a14="http://schemas.microsoft.com/office/drawing/2010/main" Requires="a14">
+      <mc:AlternateContent xmlns:mc="http://schemas.openxmlformats.org/markup-compatibility/2006" xmlns:a14="http://schemas.microsoft.com/office/drawing/2010/main">
+        <mc:Choice Requires="a14">
           <p:sp>
             <p:nvSpPr>
               <p:cNvPr id="14" name="TextBox 13">
@@ -22641,7 +22887,7 @@
             </p:txBody>
           </p:sp>
         </mc:Choice>
-        <mc:Fallback>
+        <mc:Fallback xmlns="">
           <p:sp>
             <p:nvSpPr>
               <p:cNvPr id="14" name="TextBox 13">
@@ -23039,8 +23285,8 @@
           </a:extLst>
         </p:spPr>
       </p:pic>
-      <mc:AlternateContent xmlns:mc="http://schemas.openxmlformats.org/markup-compatibility/2006">
-        <mc:Choice xmlns:a14="http://schemas.microsoft.com/office/drawing/2010/main" Requires="a14">
+      <mc:AlternateContent xmlns:mc="http://schemas.openxmlformats.org/markup-compatibility/2006" xmlns:a14="http://schemas.microsoft.com/office/drawing/2010/main">
+        <mc:Choice Requires="a14">
           <p:sp>
             <p:nvSpPr>
               <p:cNvPr id="26" name="TextBox 25">
@@ -23130,7 +23376,7 @@
             </p:txBody>
           </p:sp>
         </mc:Choice>
-        <mc:Fallback>
+        <mc:Fallback xmlns="">
           <p:sp>
             <p:nvSpPr>
               <p:cNvPr id="26" name="TextBox 25">
@@ -23899,8 +24145,8 @@
           </a:p>
         </p:txBody>
       </p:sp>
-      <mc:AlternateContent xmlns:mc="http://schemas.openxmlformats.org/markup-compatibility/2006">
-        <mc:Choice xmlns:a14="http://schemas.microsoft.com/office/drawing/2010/main" Requires="a14">
+      <mc:AlternateContent xmlns:mc="http://schemas.openxmlformats.org/markup-compatibility/2006" xmlns:a14="http://schemas.microsoft.com/office/drawing/2010/main">
+        <mc:Choice Requires="a14">
           <p:sp>
             <p:nvSpPr>
               <p:cNvPr id="6" name="TextBox 5">
@@ -23975,7 +24221,7 @@
             </p:txBody>
           </p:sp>
         </mc:Choice>
-        <mc:Fallback>
+        <mc:Fallback xmlns="">
           <p:sp>
             <p:nvSpPr>
               <p:cNvPr id="6" name="TextBox 5">
@@ -28591,6 +28837,90 @@
           </a:p>
         </p:txBody>
       </p:sp>
+      <p:cxnSp>
+        <p:nvCxnSpPr>
+          <p:cNvPr id="7" name="Straight Connector 6">
+            <a:extLst>
+              <a:ext uri="{FF2B5EF4-FFF2-40B4-BE49-F238E27FC236}">
+                <a16:creationId xmlns:a16="http://schemas.microsoft.com/office/drawing/2014/main" id="{46EF085C-89C3-AE54-DD62-A263C92BAB49}"/>
+              </a:ext>
+            </a:extLst>
+          </p:cNvPr>
+          <p:cNvCxnSpPr/>
+          <p:nvPr/>
+        </p:nvCxnSpPr>
+        <p:spPr>
+          <a:xfrm>
+            <a:off x="5208815" y="3608615"/>
+            <a:ext cx="538842" cy="0"/>
+          </a:xfrm>
+          <a:prstGeom prst="line">
+            <a:avLst/>
+          </a:prstGeom>
+          <a:ln w="57150">
+            <a:solidFill>
+              <a:schemeClr val="accent4"/>
+            </a:solidFill>
+          </a:ln>
+        </p:spPr>
+        <p:style>
+          <a:lnRef idx="2">
+            <a:schemeClr val="accent1"/>
+          </a:lnRef>
+          <a:fillRef idx="0">
+            <a:schemeClr val="accent1"/>
+          </a:fillRef>
+          <a:effectRef idx="1">
+            <a:schemeClr val="accent1"/>
+          </a:effectRef>
+          <a:fontRef idx="minor">
+            <a:schemeClr val="tx1"/>
+          </a:fontRef>
+        </p:style>
+      </p:cxnSp>
+      <p:cxnSp>
+        <p:nvCxnSpPr>
+          <p:cNvPr id="8" name="Straight Connector 7">
+            <a:extLst>
+              <a:ext uri="{FF2B5EF4-FFF2-40B4-BE49-F238E27FC236}">
+                <a16:creationId xmlns:a16="http://schemas.microsoft.com/office/drawing/2014/main" id="{3B7CF570-41F7-0302-C8C1-0EAF133032AB}"/>
+              </a:ext>
+            </a:extLst>
+          </p:cNvPr>
+          <p:cNvCxnSpPr>
+            <a:cxnSpLocks/>
+          </p:cNvCxnSpPr>
+          <p:nvPr/>
+        </p:nvCxnSpPr>
+        <p:spPr>
+          <a:xfrm>
+            <a:off x="5981700" y="3608615"/>
+            <a:ext cx="1643743" cy="0"/>
+          </a:xfrm>
+          <a:prstGeom prst="line">
+            <a:avLst/>
+          </a:prstGeom>
+          <a:ln w="57150">
+            <a:solidFill>
+              <a:schemeClr val="accent4"/>
+            </a:solidFill>
+          </a:ln>
+        </p:spPr>
+        <p:style>
+          <a:lnRef idx="2">
+            <a:schemeClr val="accent1"/>
+          </a:lnRef>
+          <a:fillRef idx="0">
+            <a:schemeClr val="accent1"/>
+          </a:fillRef>
+          <a:effectRef idx="1">
+            <a:schemeClr val="accent1"/>
+          </a:effectRef>
+          <a:fontRef idx="minor">
+            <a:schemeClr val="tx1"/>
+          </a:fontRef>
+        </p:style>
+      </p:cxnSp>
     </p:spTree>
     <p:extLst>
       <p:ext uri="{BB962C8B-B14F-4D97-AF65-F5344CB8AC3E}">
@@ -28715,11 +29045,7 @@
                                           </p:stCondLst>
                                         </p:cTn>
                                         <p:tgtEl>
-                                          <p:spTgt spid="5">
-                                            <p:txEl>
-                                              <p:pRg st="5" end="5"/>
-                                            </p:txEl>
-                                          </p:spTgt>
+                                          <p:spTgt spid="7"/>
                                         </p:tgtEl>
                                         <p:attrNameLst>
                                           <p:attrName>style.visibility</p:attrName>
@@ -28751,7 +29077,7 @@
                             </p:stCondLst>
                             <p:childTnLst>
                               <p:par>
-                                <p:cTn id="15" presetID="1" presetClass="entr" presetSubtype="0" fill="hold" nodeType="clickEffect">
+                                <p:cTn id="15" presetID="1" presetClass="exit" presetSubtype="0" fill="hold" nodeType="clickEffect">
                                   <p:stCondLst>
                                     <p:cond delay="0"/>
                                   </p:stCondLst>
@@ -28759,6 +29085,190 @@
                                     <p:set>
                                       <p:cBhvr>
                                         <p:cTn id="16" dur="1" fill="hold">
+                                          <p:stCondLst>
+                                            <p:cond delay="0"/>
+                                          </p:stCondLst>
+                                        </p:cTn>
+                                        <p:tgtEl>
+                                          <p:spTgt spid="7"/>
+                                        </p:tgtEl>
+                                        <p:attrNameLst>
+                                          <p:attrName>style.visibility</p:attrName>
+                                        </p:attrNameLst>
+                                      </p:cBhvr>
+                                      <p:to>
+                                        <p:strVal val="hidden"/>
+                                      </p:to>
+                                    </p:set>
+                                  </p:childTnLst>
+                                </p:cTn>
+                              </p:par>
+                            </p:childTnLst>
+                          </p:cTn>
+                        </p:par>
+                      </p:childTnLst>
+                    </p:cTn>
+                  </p:par>
+                  <p:par>
+                    <p:cTn id="17" fill="hold">
+                      <p:stCondLst>
+                        <p:cond delay="indefinite"/>
+                      </p:stCondLst>
+                      <p:childTnLst>
+                        <p:par>
+                          <p:cTn id="18" fill="hold">
+                            <p:stCondLst>
+                              <p:cond delay="0"/>
+                            </p:stCondLst>
+                            <p:childTnLst>
+                              <p:par>
+                                <p:cTn id="19" presetID="1" presetClass="entr" presetSubtype="0" fill="hold" nodeType="clickEffect">
+                                  <p:stCondLst>
+                                    <p:cond delay="0"/>
+                                  </p:stCondLst>
+                                  <p:childTnLst>
+                                    <p:set>
+                                      <p:cBhvr>
+                                        <p:cTn id="20" dur="1" fill="hold">
+                                          <p:stCondLst>
+                                            <p:cond delay="0"/>
+                                          </p:stCondLst>
+                                        </p:cTn>
+                                        <p:tgtEl>
+                                          <p:spTgt spid="8"/>
+                                        </p:tgtEl>
+                                        <p:attrNameLst>
+                                          <p:attrName>style.visibility</p:attrName>
+                                        </p:attrNameLst>
+                                      </p:cBhvr>
+                                      <p:to>
+                                        <p:strVal val="visible"/>
+                                      </p:to>
+                                    </p:set>
+                                  </p:childTnLst>
+                                </p:cTn>
+                              </p:par>
+                            </p:childTnLst>
+                          </p:cTn>
+                        </p:par>
+                      </p:childTnLst>
+                    </p:cTn>
+                  </p:par>
+                  <p:par>
+                    <p:cTn id="21" fill="hold">
+                      <p:stCondLst>
+                        <p:cond delay="indefinite"/>
+                      </p:stCondLst>
+                      <p:childTnLst>
+                        <p:par>
+                          <p:cTn id="22" fill="hold">
+                            <p:stCondLst>
+                              <p:cond delay="0"/>
+                            </p:stCondLst>
+                            <p:childTnLst>
+                              <p:par>
+                                <p:cTn id="23" presetID="1" presetClass="exit" presetSubtype="0" fill="hold" nodeType="clickEffect">
+                                  <p:stCondLst>
+                                    <p:cond delay="0"/>
+                                  </p:stCondLst>
+                                  <p:childTnLst>
+                                    <p:set>
+                                      <p:cBhvr>
+                                        <p:cTn id="24" dur="1" fill="hold">
+                                          <p:stCondLst>
+                                            <p:cond delay="0"/>
+                                          </p:stCondLst>
+                                        </p:cTn>
+                                        <p:tgtEl>
+                                          <p:spTgt spid="8"/>
+                                        </p:tgtEl>
+                                        <p:attrNameLst>
+                                          <p:attrName>style.visibility</p:attrName>
+                                        </p:attrNameLst>
+                                      </p:cBhvr>
+                                      <p:to>
+                                        <p:strVal val="hidden"/>
+                                      </p:to>
+                                    </p:set>
+                                  </p:childTnLst>
+                                </p:cTn>
+                              </p:par>
+                            </p:childTnLst>
+                          </p:cTn>
+                        </p:par>
+                      </p:childTnLst>
+                    </p:cTn>
+                  </p:par>
+                  <p:par>
+                    <p:cTn id="25" fill="hold">
+                      <p:stCondLst>
+                        <p:cond delay="indefinite"/>
+                      </p:stCondLst>
+                      <p:childTnLst>
+                        <p:par>
+                          <p:cTn id="26" fill="hold">
+                            <p:stCondLst>
+                              <p:cond delay="0"/>
+                            </p:stCondLst>
+                            <p:childTnLst>
+                              <p:par>
+                                <p:cTn id="27" presetID="1" presetClass="entr" presetSubtype="0" fill="hold" nodeType="clickEffect">
+                                  <p:stCondLst>
+                                    <p:cond delay="0"/>
+                                  </p:stCondLst>
+                                  <p:childTnLst>
+                                    <p:set>
+                                      <p:cBhvr>
+                                        <p:cTn id="28" dur="1" fill="hold">
+                                          <p:stCondLst>
+                                            <p:cond delay="0"/>
+                                          </p:stCondLst>
+                                        </p:cTn>
+                                        <p:tgtEl>
+                                          <p:spTgt spid="5">
+                                            <p:txEl>
+                                              <p:pRg st="5" end="5"/>
+                                            </p:txEl>
+                                          </p:spTgt>
+                                        </p:tgtEl>
+                                        <p:attrNameLst>
+                                          <p:attrName>style.visibility</p:attrName>
+                                        </p:attrNameLst>
+                                      </p:cBhvr>
+                                      <p:to>
+                                        <p:strVal val="visible"/>
+                                      </p:to>
+                                    </p:set>
+                                  </p:childTnLst>
+                                </p:cTn>
+                              </p:par>
+                            </p:childTnLst>
+                          </p:cTn>
+                        </p:par>
+                      </p:childTnLst>
+                    </p:cTn>
+                  </p:par>
+                  <p:par>
+                    <p:cTn id="29" fill="hold">
+                      <p:stCondLst>
+                        <p:cond delay="indefinite"/>
+                      </p:stCondLst>
+                      <p:childTnLst>
+                        <p:par>
+                          <p:cTn id="30" fill="hold">
+                            <p:stCondLst>
+                              <p:cond delay="0"/>
+                            </p:stCondLst>
+                            <p:childTnLst>
+                              <p:par>
+                                <p:cTn id="31" presetID="1" presetClass="entr" presetSubtype="0" fill="hold" nodeType="clickEffect">
+                                  <p:stCondLst>
+                                    <p:cond delay="0"/>
+                                  </p:stCondLst>
+                                  <p:childTnLst>
+                                    <p:set>
+                                      <p:cBhvr>
+                                        <p:cTn id="32" dur="1" fill="hold">
                                           <p:stCondLst>
                                             <p:cond delay="0"/>
                                           </p:stCondLst>
@@ -28778,14 +29288,14 @@
                                 </p:cTn>
                               </p:par>
                               <p:par>
-                                <p:cTn id="17" presetID="1" presetClass="entr" presetSubtype="0" fill="hold" grpId="0" nodeType="withEffect">
+                                <p:cTn id="33" presetID="1" presetClass="entr" presetSubtype="0" fill="hold" grpId="0" nodeType="withEffect">
                                   <p:stCondLst>
                                     <p:cond delay="0"/>
                                   </p:stCondLst>
                                   <p:childTnLst>
                                     <p:set>
                                       <p:cBhvr>
-                                        <p:cTn id="18" dur="1" fill="hold">
+                                        <p:cTn id="34" dur="1" fill="hold">
                                           <p:stCondLst>
                                             <p:cond delay="0"/>
                                           </p:stCondLst>
@@ -29355,6 +29865,135 @@
           </a:p>
         </p:txBody>
       </p:sp>
+      <p:cxnSp>
+        <p:nvCxnSpPr>
+          <p:cNvPr id="3" name="Straight Connector 2">
+            <a:extLst>
+              <a:ext uri="{FF2B5EF4-FFF2-40B4-BE49-F238E27FC236}">
+                <a16:creationId xmlns:a16="http://schemas.microsoft.com/office/drawing/2014/main" id="{2E5D2E7F-9CC7-28D5-EC05-48C6CDC8C0FB}"/>
+              </a:ext>
+            </a:extLst>
+          </p:cNvPr>
+          <p:cNvCxnSpPr>
+            <a:cxnSpLocks/>
+          </p:cNvCxnSpPr>
+          <p:nvPr/>
+        </p:nvCxnSpPr>
+        <p:spPr>
+          <a:xfrm>
+            <a:off x="3581400" y="2955472"/>
+            <a:ext cx="1807029" cy="0"/>
+          </a:xfrm>
+          <a:prstGeom prst="line">
+            <a:avLst/>
+          </a:prstGeom>
+          <a:ln w="57150">
+            <a:solidFill>
+              <a:schemeClr val="accent4"/>
+            </a:solidFill>
+          </a:ln>
+        </p:spPr>
+        <p:style>
+          <a:lnRef idx="2">
+            <a:schemeClr val="accent1"/>
+          </a:lnRef>
+          <a:fillRef idx="0">
+            <a:schemeClr val="accent1"/>
+          </a:fillRef>
+          <a:effectRef idx="1">
+            <a:schemeClr val="accent1"/>
+          </a:effectRef>
+          <a:fontRef idx="minor">
+            <a:schemeClr val="tx1"/>
+          </a:fontRef>
+        </p:style>
+      </p:cxnSp>
+      <p:cxnSp>
+        <p:nvCxnSpPr>
+          <p:cNvPr id="6" name="Straight Connector 5">
+            <a:extLst>
+              <a:ext uri="{FF2B5EF4-FFF2-40B4-BE49-F238E27FC236}">
+                <a16:creationId xmlns:a16="http://schemas.microsoft.com/office/drawing/2014/main" id="{4670AD79-099C-8DB1-77D3-0C764CC91F5B}"/>
+              </a:ext>
+            </a:extLst>
+          </p:cNvPr>
+          <p:cNvCxnSpPr>
+            <a:cxnSpLocks/>
+          </p:cNvCxnSpPr>
+          <p:nvPr/>
+        </p:nvCxnSpPr>
+        <p:spPr>
+          <a:xfrm>
+            <a:off x="5981700" y="2955472"/>
+            <a:ext cx="2198914" cy="0"/>
+          </a:xfrm>
+          <a:prstGeom prst="line">
+            <a:avLst/>
+          </a:prstGeom>
+          <a:ln w="57150">
+            <a:solidFill>
+              <a:schemeClr val="accent4"/>
+            </a:solidFill>
+          </a:ln>
+        </p:spPr>
+        <p:style>
+          <a:lnRef idx="2">
+            <a:schemeClr val="accent1"/>
+          </a:lnRef>
+          <a:fillRef idx="0">
+            <a:schemeClr val="accent1"/>
+          </a:fillRef>
+          <a:effectRef idx="1">
+            <a:schemeClr val="accent1"/>
+          </a:effectRef>
+          <a:fontRef idx="minor">
+            <a:schemeClr val="tx1"/>
+          </a:fontRef>
+        </p:style>
+      </p:cxnSp>
+      <p:cxnSp>
+        <p:nvCxnSpPr>
+          <p:cNvPr id="7" name="Straight Connector 6">
+            <a:extLst>
+              <a:ext uri="{FF2B5EF4-FFF2-40B4-BE49-F238E27FC236}">
+                <a16:creationId xmlns:a16="http://schemas.microsoft.com/office/drawing/2014/main" id="{05985566-36A8-A889-1B9F-E691892B2F0B}"/>
+              </a:ext>
+            </a:extLst>
+          </p:cNvPr>
+          <p:cNvCxnSpPr>
+            <a:cxnSpLocks/>
+          </p:cNvCxnSpPr>
+          <p:nvPr/>
+        </p:nvCxnSpPr>
+        <p:spPr>
+          <a:xfrm>
+            <a:off x="8730343" y="2955472"/>
+            <a:ext cx="1148443" cy="0"/>
+          </a:xfrm>
+          <a:prstGeom prst="line">
+            <a:avLst/>
+          </a:prstGeom>
+          <a:ln w="57150">
+            <a:solidFill>
+              <a:schemeClr val="accent4"/>
+            </a:solidFill>
+          </a:ln>
+        </p:spPr>
+        <p:style>
+          <a:lnRef idx="2">
+            <a:schemeClr val="accent1"/>
+          </a:lnRef>
+          <a:fillRef idx="0">
+            <a:schemeClr val="accent1"/>
+          </a:fillRef>
+          <a:effectRef idx="1">
+            <a:schemeClr val="accent1"/>
+          </a:effectRef>
+          <a:fontRef idx="minor">
+            <a:schemeClr val="tx1"/>
+          </a:fontRef>
+        </p:style>
+      </p:cxnSp>
     </p:spTree>
     <p:extLst>
       <p:ext uri="{BB962C8B-B14F-4D97-AF65-F5344CB8AC3E}">
@@ -29399,11 +30038,7 @@
                                           </p:stCondLst>
                                         </p:cTn>
                                         <p:tgtEl>
-                                          <p:spTgt spid="5">
-                                            <p:txEl>
-                                              <p:pRg st="3" end="3"/>
-                                            </p:txEl>
-                                          </p:spTgt>
+                                          <p:spTgt spid="3"/>
                                         </p:tgtEl>
                                         <p:attrNameLst>
                                           <p:attrName>style.visibility</p:attrName>
@@ -29435,7 +30070,7 @@
                             </p:stCondLst>
                             <p:childTnLst>
                               <p:par>
-                                <p:cTn id="9" presetID="1" presetClass="entr" presetSubtype="0" fill="hold" nodeType="clickEffect">
+                                <p:cTn id="9" presetID="1" presetClass="exit" presetSubtype="0" fill="hold" nodeType="clickEffect">
                                   <p:stCondLst>
                                     <p:cond delay="0"/>
                                   </p:stCondLst>
@@ -29443,6 +30078,280 @@
                                     <p:set>
                                       <p:cBhvr>
                                         <p:cTn id="10" dur="1" fill="hold">
+                                          <p:stCondLst>
+                                            <p:cond delay="0"/>
+                                          </p:stCondLst>
+                                        </p:cTn>
+                                        <p:tgtEl>
+                                          <p:spTgt spid="3"/>
+                                        </p:tgtEl>
+                                        <p:attrNameLst>
+                                          <p:attrName>style.visibility</p:attrName>
+                                        </p:attrNameLst>
+                                      </p:cBhvr>
+                                      <p:to>
+                                        <p:strVal val="hidden"/>
+                                      </p:to>
+                                    </p:set>
+                                  </p:childTnLst>
+                                </p:cTn>
+                              </p:par>
+                            </p:childTnLst>
+                          </p:cTn>
+                        </p:par>
+                      </p:childTnLst>
+                    </p:cTn>
+                  </p:par>
+                  <p:par>
+                    <p:cTn id="11" fill="hold">
+                      <p:stCondLst>
+                        <p:cond delay="indefinite"/>
+                      </p:stCondLst>
+                      <p:childTnLst>
+                        <p:par>
+                          <p:cTn id="12" fill="hold">
+                            <p:stCondLst>
+                              <p:cond delay="0"/>
+                            </p:stCondLst>
+                            <p:childTnLst>
+                              <p:par>
+                                <p:cTn id="13" presetID="1" presetClass="entr" presetSubtype="0" fill="hold" nodeType="clickEffect">
+                                  <p:stCondLst>
+                                    <p:cond delay="0"/>
+                                  </p:stCondLst>
+                                  <p:childTnLst>
+                                    <p:set>
+                                      <p:cBhvr>
+                                        <p:cTn id="14" dur="1" fill="hold">
+                                          <p:stCondLst>
+                                            <p:cond delay="0"/>
+                                          </p:stCondLst>
+                                        </p:cTn>
+                                        <p:tgtEl>
+                                          <p:spTgt spid="6"/>
+                                        </p:tgtEl>
+                                        <p:attrNameLst>
+                                          <p:attrName>style.visibility</p:attrName>
+                                        </p:attrNameLst>
+                                      </p:cBhvr>
+                                      <p:to>
+                                        <p:strVal val="visible"/>
+                                      </p:to>
+                                    </p:set>
+                                  </p:childTnLst>
+                                </p:cTn>
+                              </p:par>
+                            </p:childTnLst>
+                          </p:cTn>
+                        </p:par>
+                      </p:childTnLst>
+                    </p:cTn>
+                  </p:par>
+                  <p:par>
+                    <p:cTn id="15" fill="hold">
+                      <p:stCondLst>
+                        <p:cond delay="indefinite"/>
+                      </p:stCondLst>
+                      <p:childTnLst>
+                        <p:par>
+                          <p:cTn id="16" fill="hold">
+                            <p:stCondLst>
+                              <p:cond delay="0"/>
+                            </p:stCondLst>
+                            <p:childTnLst>
+                              <p:par>
+                                <p:cTn id="17" presetID="1" presetClass="exit" presetSubtype="0" fill="hold" nodeType="clickEffect">
+                                  <p:stCondLst>
+                                    <p:cond delay="0"/>
+                                  </p:stCondLst>
+                                  <p:childTnLst>
+                                    <p:set>
+                                      <p:cBhvr>
+                                        <p:cTn id="18" dur="1" fill="hold">
+                                          <p:stCondLst>
+                                            <p:cond delay="0"/>
+                                          </p:stCondLst>
+                                        </p:cTn>
+                                        <p:tgtEl>
+                                          <p:spTgt spid="6"/>
+                                        </p:tgtEl>
+                                        <p:attrNameLst>
+                                          <p:attrName>style.visibility</p:attrName>
+                                        </p:attrNameLst>
+                                      </p:cBhvr>
+                                      <p:to>
+                                        <p:strVal val="hidden"/>
+                                      </p:to>
+                                    </p:set>
+                                  </p:childTnLst>
+                                </p:cTn>
+                              </p:par>
+                            </p:childTnLst>
+                          </p:cTn>
+                        </p:par>
+                      </p:childTnLst>
+                    </p:cTn>
+                  </p:par>
+                  <p:par>
+                    <p:cTn id="19" fill="hold">
+                      <p:stCondLst>
+                        <p:cond delay="indefinite"/>
+                      </p:stCondLst>
+                      <p:childTnLst>
+                        <p:par>
+                          <p:cTn id="20" fill="hold">
+                            <p:stCondLst>
+                              <p:cond delay="0"/>
+                            </p:stCondLst>
+                            <p:childTnLst>
+                              <p:par>
+                                <p:cTn id="21" presetID="1" presetClass="entr" presetSubtype="0" fill="hold" nodeType="clickEffect">
+                                  <p:stCondLst>
+                                    <p:cond delay="0"/>
+                                  </p:stCondLst>
+                                  <p:childTnLst>
+                                    <p:set>
+                                      <p:cBhvr>
+                                        <p:cTn id="22" dur="1" fill="hold">
+                                          <p:stCondLst>
+                                            <p:cond delay="0"/>
+                                          </p:stCondLst>
+                                        </p:cTn>
+                                        <p:tgtEl>
+                                          <p:spTgt spid="7"/>
+                                        </p:tgtEl>
+                                        <p:attrNameLst>
+                                          <p:attrName>style.visibility</p:attrName>
+                                        </p:attrNameLst>
+                                      </p:cBhvr>
+                                      <p:to>
+                                        <p:strVal val="visible"/>
+                                      </p:to>
+                                    </p:set>
+                                  </p:childTnLst>
+                                </p:cTn>
+                              </p:par>
+                            </p:childTnLst>
+                          </p:cTn>
+                        </p:par>
+                      </p:childTnLst>
+                    </p:cTn>
+                  </p:par>
+                  <p:par>
+                    <p:cTn id="23" fill="hold">
+                      <p:stCondLst>
+                        <p:cond delay="indefinite"/>
+                      </p:stCondLst>
+                      <p:childTnLst>
+                        <p:par>
+                          <p:cTn id="24" fill="hold">
+                            <p:stCondLst>
+                              <p:cond delay="0"/>
+                            </p:stCondLst>
+                            <p:childTnLst>
+                              <p:par>
+                                <p:cTn id="25" presetID="1" presetClass="exit" presetSubtype="0" fill="hold" nodeType="clickEffect">
+                                  <p:stCondLst>
+                                    <p:cond delay="0"/>
+                                  </p:stCondLst>
+                                  <p:childTnLst>
+                                    <p:set>
+                                      <p:cBhvr>
+                                        <p:cTn id="26" dur="1" fill="hold">
+                                          <p:stCondLst>
+                                            <p:cond delay="0"/>
+                                          </p:stCondLst>
+                                        </p:cTn>
+                                        <p:tgtEl>
+                                          <p:spTgt spid="7"/>
+                                        </p:tgtEl>
+                                        <p:attrNameLst>
+                                          <p:attrName>style.visibility</p:attrName>
+                                        </p:attrNameLst>
+                                      </p:cBhvr>
+                                      <p:to>
+                                        <p:strVal val="hidden"/>
+                                      </p:to>
+                                    </p:set>
+                                  </p:childTnLst>
+                                </p:cTn>
+                              </p:par>
+                            </p:childTnLst>
+                          </p:cTn>
+                        </p:par>
+                      </p:childTnLst>
+                    </p:cTn>
+                  </p:par>
+                  <p:par>
+                    <p:cTn id="27" fill="hold">
+                      <p:stCondLst>
+                        <p:cond delay="indefinite"/>
+                      </p:stCondLst>
+                      <p:childTnLst>
+                        <p:par>
+                          <p:cTn id="28" fill="hold">
+                            <p:stCondLst>
+                              <p:cond delay="0"/>
+                            </p:stCondLst>
+                            <p:childTnLst>
+                              <p:par>
+                                <p:cTn id="29" presetID="1" presetClass="entr" presetSubtype="0" fill="hold" nodeType="clickEffect">
+                                  <p:stCondLst>
+                                    <p:cond delay="0"/>
+                                  </p:stCondLst>
+                                  <p:childTnLst>
+                                    <p:set>
+                                      <p:cBhvr>
+                                        <p:cTn id="30" dur="1" fill="hold">
+                                          <p:stCondLst>
+                                            <p:cond delay="0"/>
+                                          </p:stCondLst>
+                                        </p:cTn>
+                                        <p:tgtEl>
+                                          <p:spTgt spid="5">
+                                            <p:txEl>
+                                              <p:pRg st="3" end="3"/>
+                                            </p:txEl>
+                                          </p:spTgt>
+                                        </p:tgtEl>
+                                        <p:attrNameLst>
+                                          <p:attrName>style.visibility</p:attrName>
+                                        </p:attrNameLst>
+                                      </p:cBhvr>
+                                      <p:to>
+                                        <p:strVal val="visible"/>
+                                      </p:to>
+                                    </p:set>
+                                  </p:childTnLst>
+                                </p:cTn>
+                              </p:par>
+                            </p:childTnLst>
+                          </p:cTn>
+                        </p:par>
+                      </p:childTnLst>
+                    </p:cTn>
+                  </p:par>
+                  <p:par>
+                    <p:cTn id="31" fill="hold">
+                      <p:stCondLst>
+                        <p:cond delay="indefinite"/>
+                      </p:stCondLst>
+                      <p:childTnLst>
+                        <p:par>
+                          <p:cTn id="32" fill="hold">
+                            <p:stCondLst>
+                              <p:cond delay="0"/>
+                            </p:stCondLst>
+                            <p:childTnLst>
+                              <p:par>
+                                <p:cTn id="33" presetID="1" presetClass="entr" presetSubtype="0" fill="hold" nodeType="clickEffect">
+                                  <p:stCondLst>
+                                    <p:cond delay="0"/>
+                                  </p:stCondLst>
+                                  <p:childTnLst>
+                                    <p:set>
+                                      <p:cBhvr>
+                                        <p:cTn id="34" dur="1" fill="hold">
                                           <p:stCondLst>
                                             <p:cond delay="0"/>
                                           </p:stCondLst>
@@ -29466,14 +30375,14 @@
                                 </p:cTn>
                               </p:par>
                               <p:par>
-                                <p:cTn id="11" presetID="1" presetClass="entr" presetSubtype="0" fill="hold" nodeType="withEffect">
+                                <p:cTn id="35" presetID="1" presetClass="entr" presetSubtype="0" fill="hold" nodeType="withEffect">
                                   <p:stCondLst>
                                     <p:cond delay="0"/>
                                   </p:stCondLst>
                                   <p:childTnLst>
                                     <p:set>
                                       <p:cBhvr>
-                                        <p:cTn id="12" dur="1" fill="hold">
+                                        <p:cTn id="36" dur="1" fill="hold">
                                           <p:stCondLst>
                                             <p:cond delay="0"/>
                                           </p:stCondLst>
@@ -30222,8 +31131,8 @@
           </a:p>
         </p:txBody>
       </p:sp>
-      <mc:AlternateContent xmlns:mc="http://schemas.openxmlformats.org/markup-compatibility/2006">
-        <mc:Choice xmlns:a14="http://schemas.microsoft.com/office/drawing/2010/main" Requires="a14">
+      <mc:AlternateContent xmlns:mc="http://schemas.openxmlformats.org/markup-compatibility/2006" xmlns:a14="http://schemas.microsoft.com/office/drawing/2010/main">
+        <mc:Choice Requires="a14">
           <p:sp>
             <p:nvSpPr>
               <p:cNvPr id="3" name="TextBox 2">
@@ -30369,7 +31278,7 @@
             </p:txBody>
           </p:sp>
         </mc:Choice>
-        <mc:Fallback>
+        <mc:Fallback xmlns="">
           <p:sp>
             <p:nvSpPr>
               <p:cNvPr id="3" name="TextBox 2">
@@ -31205,6 +32114,49 @@
           </a:p>
         </p:txBody>
       </p:sp>
+      <p:cxnSp>
+        <p:nvCxnSpPr>
+          <p:cNvPr id="3" name="Straight Connector 2">
+            <a:extLst>
+              <a:ext uri="{FF2B5EF4-FFF2-40B4-BE49-F238E27FC236}">
+                <a16:creationId xmlns:a16="http://schemas.microsoft.com/office/drawing/2014/main" id="{46978DD1-1857-8461-6855-F665F278DE8E}"/>
+              </a:ext>
+            </a:extLst>
+          </p:cNvPr>
+          <p:cNvCxnSpPr>
+            <a:cxnSpLocks/>
+          </p:cNvCxnSpPr>
+          <p:nvPr/>
+        </p:nvCxnSpPr>
+        <p:spPr>
+          <a:xfrm>
+            <a:off x="5517777" y="3762296"/>
+            <a:ext cx="372035" cy="0"/>
+          </a:xfrm>
+          <a:prstGeom prst="line">
+            <a:avLst/>
+          </a:prstGeom>
+          <a:ln w="57150">
+            <a:solidFill>
+              <a:schemeClr val="accent4"/>
+            </a:solidFill>
+          </a:ln>
+        </p:spPr>
+        <p:style>
+          <a:lnRef idx="2">
+            <a:schemeClr val="accent1"/>
+          </a:lnRef>
+          <a:fillRef idx="0">
+            <a:schemeClr val="accent1"/>
+          </a:fillRef>
+          <a:effectRef idx="1">
+            <a:schemeClr val="accent1"/>
+          </a:effectRef>
+          <a:fontRef idx="minor">
+            <a:schemeClr val="tx1"/>
+          </a:fontRef>
+        </p:style>
+      </p:cxnSp>
     </p:spTree>
     <p:extLst>
       <p:ext uri="{BB962C8B-B14F-4D97-AF65-F5344CB8AC3E}">
@@ -31378,6 +32330,96 @@
                                           </p:stCondLst>
                                         </p:cTn>
                                         <p:tgtEl>
+                                          <p:spTgt spid="3"/>
+                                        </p:tgtEl>
+                                        <p:attrNameLst>
+                                          <p:attrName>style.visibility</p:attrName>
+                                        </p:attrNameLst>
+                                      </p:cBhvr>
+                                      <p:to>
+                                        <p:strVal val="visible"/>
+                                      </p:to>
+                                    </p:set>
+                                  </p:childTnLst>
+                                </p:cTn>
+                              </p:par>
+                            </p:childTnLst>
+                          </p:cTn>
+                        </p:par>
+                      </p:childTnLst>
+                    </p:cTn>
+                  </p:par>
+                  <p:par>
+                    <p:cTn id="17" fill="hold">
+                      <p:stCondLst>
+                        <p:cond delay="indefinite"/>
+                      </p:stCondLst>
+                      <p:childTnLst>
+                        <p:par>
+                          <p:cTn id="18" fill="hold">
+                            <p:stCondLst>
+                              <p:cond delay="0"/>
+                            </p:stCondLst>
+                            <p:childTnLst>
+                              <p:par>
+                                <p:cTn id="19" presetID="1" presetClass="exit" presetSubtype="0" fill="hold" nodeType="clickEffect">
+                                  <p:stCondLst>
+                                    <p:cond delay="0"/>
+                                  </p:stCondLst>
+                                  <p:childTnLst>
+                                    <p:set>
+                                      <p:cBhvr>
+                                        <p:cTn id="20" dur="1" fill="hold">
+                                          <p:stCondLst>
+                                            <p:cond delay="0"/>
+                                          </p:stCondLst>
+                                        </p:cTn>
+                                        <p:tgtEl>
+                                          <p:spTgt spid="3"/>
+                                        </p:tgtEl>
+                                        <p:attrNameLst>
+                                          <p:attrName>style.visibility</p:attrName>
+                                        </p:attrNameLst>
+                                      </p:cBhvr>
+                                      <p:to>
+                                        <p:strVal val="hidden"/>
+                                      </p:to>
+                                    </p:set>
+                                  </p:childTnLst>
+                                </p:cTn>
+                              </p:par>
+                            </p:childTnLst>
+                          </p:cTn>
+                        </p:par>
+                      </p:childTnLst>
+                    </p:cTn>
+                  </p:par>
+                  <p:par>
+                    <p:cTn id="21" fill="hold">
+                      <p:stCondLst>
+                        <p:cond delay="indefinite"/>
+                      </p:stCondLst>
+                      <p:childTnLst>
+                        <p:par>
+                          <p:cTn id="22" fill="hold">
+                            <p:stCondLst>
+                              <p:cond delay="0"/>
+                            </p:stCondLst>
+                            <p:childTnLst>
+                              <p:par>
+                                <p:cTn id="23" presetID="1" presetClass="entr" presetSubtype="0" fill="hold" nodeType="clickEffect">
+                                  <p:stCondLst>
+                                    <p:cond delay="0"/>
+                                  </p:stCondLst>
+                                  <p:childTnLst>
+                                    <p:set>
+                                      <p:cBhvr>
+                                        <p:cTn id="24" dur="1" fill="hold">
+                                          <p:stCondLst>
+                                            <p:cond delay="0"/>
+                                          </p:stCondLst>
+                                        </p:cTn>
+                                        <p:tgtEl>
                                           <p:spTgt spid="5">
                                             <p:txEl>
                                               <p:pRg st="6" end="6"/>
@@ -31635,7 +32677,7 @@
                 <a:effectLst/>
                 <a:latin typeface="Menlo" panose="020B0609030804020204" pitchFamily="49" charset="0"/>
               </a:rPr>
-              <a:t># k vs WSSD</a:t>
+              <a:t># k vs Total WSSD</a:t>
             </a:r>
             <a:endParaRPr lang="en-CA" sz="2400" b="0" dirty="0">
               <a:solidFill>
@@ -35470,6 +36512,73 @@
           <a:p>
             <a:pPr algn="l"/>
             <a:endParaRPr lang="en-US" dirty="0"/>
+          </a:p>
+        </p:txBody>
+      </p:sp>
+      <p:pic>
+        <p:nvPicPr>
+          <p:cNvPr id="3" name="Picture 2">
+            <a:extLst>
+              <a:ext uri="{FF2B5EF4-FFF2-40B4-BE49-F238E27FC236}">
+                <a16:creationId xmlns:a16="http://schemas.microsoft.com/office/drawing/2014/main" id="{49DAA2B2-8BAF-54D3-83BA-803411C0449E}"/>
+              </a:ext>
+            </a:extLst>
+          </p:cNvPr>
+          <p:cNvPicPr>
+            <a:picLocks noChangeAspect="1"/>
+          </p:cNvPicPr>
+          <p:nvPr/>
+        </p:nvPicPr>
+        <p:blipFill>
+          <a:blip r:embed="rId3"/>
+          <a:srcRect/>
+          <a:stretch/>
+        </p:blipFill>
+        <p:spPr>
+          <a:xfrm>
+            <a:off x="10668000" y="201466"/>
+            <a:ext cx="1303179" cy="1657643"/>
+          </a:xfrm>
+          <a:prstGeom prst="rect">
+            <a:avLst/>
+          </a:prstGeom>
+        </p:spPr>
+      </p:pic>
+      <p:sp>
+        <p:nvSpPr>
+          <p:cNvPr id="5" name="TextBox 4">
+            <a:extLst>
+              <a:ext uri="{FF2B5EF4-FFF2-40B4-BE49-F238E27FC236}">
+                <a16:creationId xmlns:a16="http://schemas.microsoft.com/office/drawing/2014/main" id="{3666D460-4B3E-290E-9AA2-D9D7D3192425}"/>
+              </a:ext>
+            </a:extLst>
+          </p:cNvPr>
+          <p:cNvSpPr txBox="1"/>
+          <p:nvPr/>
+        </p:nvSpPr>
+        <p:spPr>
+          <a:xfrm>
+            <a:off x="10766099" y="1489777"/>
+            <a:ext cx="1131143" cy="400110"/>
+          </a:xfrm>
+          <a:prstGeom prst="rect">
+            <a:avLst/>
+          </a:prstGeom>
+          <a:noFill/>
+        </p:spPr>
+        <p:txBody>
+          <a:bodyPr wrap="none" rtlCol="0">
+            <a:spAutoFit/>
+          </a:bodyPr>
+          <a:lstStyle/>
+          <a:p>
+            <a:r>
+              <a:rPr lang="en-US" sz="2000" dirty="0">
+                <a:latin typeface="Calibri Light" panose="020F0302020204030204" pitchFamily="34" charset="0"/>
+                <a:cs typeface="Calibri Light" panose="020F0302020204030204" pitchFamily="34" charset="0"/>
+              </a:rPr>
+              <a:t>Scan me!</a:t>
+            </a:r>
           </a:p>
         </p:txBody>
       </p:sp>
@@ -39781,8 +40890,8 @@
           </a:p>
         </p:txBody>
       </p:sp>
-      <mc:AlternateContent xmlns:mc="http://schemas.openxmlformats.org/markup-compatibility/2006">
-        <mc:Choice xmlns:a14="http://schemas.microsoft.com/office/drawing/2010/main" Requires="a14">
+      <mc:AlternateContent xmlns:mc="http://schemas.openxmlformats.org/markup-compatibility/2006" xmlns:a14="http://schemas.microsoft.com/office/drawing/2010/main">
+        <mc:Choice Requires="a14">
           <p:sp>
             <p:nvSpPr>
               <p:cNvPr id="12" name="TextBox 11">
@@ -39897,7 +41006,7 @@
             </p:txBody>
           </p:sp>
         </mc:Choice>
-        <mc:Fallback>
+        <mc:Fallback xmlns="">
           <p:sp>
             <p:nvSpPr>
               <p:cNvPr id="12" name="TextBox 11">
@@ -42397,8 +43506,8 @@
           </a:prstGeom>
         </p:spPr>
       </p:pic>
-      <mc:AlternateContent xmlns:mc="http://schemas.openxmlformats.org/markup-compatibility/2006">
-        <mc:Choice xmlns:a14="http://schemas.microsoft.com/office/drawing/2010/main" Requires="a14">
+      <mc:AlternateContent xmlns:mc="http://schemas.openxmlformats.org/markup-compatibility/2006" xmlns:a14="http://schemas.microsoft.com/office/drawing/2010/main">
+        <mc:Choice Requires="a14">
           <p:sp>
             <p:nvSpPr>
               <p:cNvPr id="3" name="Content Placeholder 2">
@@ -42781,7 +43890,7 @@
             </p:txBody>
           </p:sp>
         </mc:Choice>
-        <mc:Fallback>
+        <mc:Fallback xmlns="">
           <p:sp>
             <p:nvSpPr>
               <p:cNvPr id="3" name="Content Placeholder 2">
@@ -43451,36 +44560,6 @@
           </a:p>
         </p:txBody>
       </p:sp>
-      <p:pic>
-        <p:nvPicPr>
-          <p:cNvPr id="9" name="Picture 8" descr="A qr code on a white background&#10;&#10;Description automatically generated">
-            <a:extLst>
-              <a:ext uri="{FF2B5EF4-FFF2-40B4-BE49-F238E27FC236}">
-                <a16:creationId xmlns:a16="http://schemas.microsoft.com/office/drawing/2014/main" id="{C353142E-F8DC-2795-C0F0-509844BFCC9A}"/>
-              </a:ext>
-            </a:extLst>
-          </p:cNvPr>
-          <p:cNvPicPr>
-            <a:picLocks noChangeAspect="1"/>
-          </p:cNvPicPr>
-          <p:nvPr/>
-        </p:nvPicPr>
-        <p:blipFill>
-          <a:blip r:embed="rId5"/>
-          <a:stretch>
-            <a:fillRect/>
-          </a:stretch>
-        </p:blipFill>
-        <p:spPr>
-          <a:xfrm>
-            <a:off x="9504162" y="5406717"/>
-            <a:ext cx="1042109" cy="1325563"/>
-          </a:xfrm>
-          <a:prstGeom prst="rect">
-            <a:avLst/>
-          </a:prstGeom>
-        </p:spPr>
-      </p:pic>
     </p:spTree>
     <p:extLst>
       <p:ext uri="{BB962C8B-B14F-4D97-AF65-F5344CB8AC3E}">

</xml_diff>